<commit_message>
docs: add farmer field-validation testimonial to the conclusion
Brother (farmer) tested it on his own farm; father (agricultural
commercial) brought it to other farmers in the field. Their main
feedback was centralized data and weather-coupled disease-risk
anticipation.

Co-Authored-By: Claude Sonnet 5 <noreply@anthropic.com>
</commit_message>
<xml_diff>
--- a/SOUTENANCE.pptx
+++ b/SOUTENANCE.pptx
@@ -1045,7 +1045,7 @@
           <a:p>
             <a:r>
               <a:rPr lang="en-US" dirty="0"/>
-              <a:t>En conclusion, PlantDiag est une solution prete pour la production, conforme a cent pour cent au cahier des charges, documentee et evolutive. C'est plus qu'un exercice scolaire, c'est un produit reel utilisable des aujourd'hui.</a:t>
+              <a:t>En conclusion, PlantDiag est une solution prete pour la production, conforme a cent pour cent au cahier des charges, documentee et evolutive. Mais je voulais surtout le tester en dehors de l'ecole. Mon frere est agriculteur, il l'a teste directement dans sa ferme. Et mon pere, qui est commercial dans le secteur agricole, m'a emmene sur le terrain pour le faire essayer a plusieurs autres agriculteurs. Le retour qui revenait le plus souvent, ce n'est pas le diagnostic en lui-meme : c'est d'avoir toutes leurs donnees centralisees au meme endroit, et surtout la meteo couplee aux risques de maladie, pour pouvoir anticiper avant que le probleme n'apparaisse plutot que de le decouvrir trop tard.</a:t>
             </a:r>
             <a:endParaRPr lang="en-US" dirty="0"/>
           </a:p>
@@ -9425,12 +9425,12 @@
         </p:nvSpPr>
         <p:spPr>
           <a:xfrm>
-            <a:off x="548640" y="1645920"/>
-            <a:ext cx="5440680" cy="1463040"/>
+            <a:off x="548640" y="1572768"/>
+            <a:ext cx="5440680" cy="1207008"/>
           </a:xfrm>
           <a:prstGeom prst="roundRect">
             <a:avLst>
-              <a:gd name="adj" fmla="val 3750"/>
+              <a:gd name="adj" fmla="val 4545"/>
             </a:avLst>
           </a:prstGeom>
           <a:solidFill>
@@ -9452,24 +9452,24 @@
         </p:nvSpPr>
         <p:spPr>
           <a:xfrm>
-            <a:off x="868680" y="1901952"/>
-            <a:ext cx="4800600" cy="347472"/>
-          </a:xfrm>
-          <a:prstGeom prst="rect">
-            <a:avLst/>
-          </a:prstGeom>
-          <a:noFill/>
-          <a:ln/>
-        </p:spPr>
-        <p:txBody>
-          <a:bodyPr wrap="square" lIns="0" tIns="0" rIns="0" bIns="0" rtlCol="0" anchor="ctr"/>
-          <a:lstStyle/>
-          <a:p>
-            <a:pPr indent="0" marL="0">
-              <a:buNone/>
-            </a:pPr>
-            <a:r>
-              <a:rPr lang="en-US" sz="2000" b="1" dirty="0">
+            <a:off x="868680" y="1755648"/>
+            <a:ext cx="4800600" cy="329184"/>
+          </a:xfrm>
+          <a:prstGeom prst="rect">
+            <a:avLst/>
+          </a:prstGeom>
+          <a:noFill/>
+          <a:ln/>
+        </p:spPr>
+        <p:txBody>
+          <a:bodyPr wrap="square" lIns="0" tIns="0" rIns="0" bIns="0" rtlCol="0" anchor="ctr"/>
+          <a:lstStyle/>
+          <a:p>
+            <a:pPr indent="0" marL="0">
+              <a:buNone/>
+            </a:pPr>
+            <a:r>
+              <a:rPr lang="en-US" sz="1800" b="1" dirty="0">
                 <a:solidFill>
                   <a:srgbClr val="97BC62"/>
                 </a:solidFill>
@@ -9479,7 +9479,7 @@
               </a:rPr>
               <a:t>Fonctionnel</a:t>
             </a:r>
-            <a:endParaRPr lang="en-US" sz="2000" dirty="0"/>
+            <a:endParaRPr lang="en-US" sz="1800" dirty="0"/>
           </a:p>
         </p:txBody>
       </p:sp>
@@ -9491,24 +9491,24 @@
         </p:nvSpPr>
         <p:spPr>
           <a:xfrm>
-            <a:off x="868680" y="2331720"/>
-            <a:ext cx="4800600" cy="594360"/>
-          </a:xfrm>
-          <a:prstGeom prst="rect">
-            <a:avLst/>
-          </a:prstGeom>
-          <a:noFill/>
-          <a:ln/>
-        </p:spPr>
-        <p:txBody>
-          <a:bodyPr wrap="square" lIns="0" tIns="0" rIns="0" bIns="0" rtlCol="0" anchor="ctr"/>
-          <a:lstStyle/>
-          <a:p>
-            <a:pPr indent="0" marL="0">
-              <a:buNone/>
-            </a:pPr>
-            <a:r>
-              <a:rPr lang="en-US" sz="1300" dirty="0">
+            <a:off x="868680" y="2139696"/>
+            <a:ext cx="4800600" cy="548640"/>
+          </a:xfrm>
+          <a:prstGeom prst="rect">
+            <a:avLst/>
+          </a:prstGeom>
+          <a:noFill/>
+          <a:ln/>
+        </p:spPr>
+        <p:txBody>
+          <a:bodyPr wrap="square" lIns="0" tIns="0" rIns="0" bIns="0" rtlCol="0" anchor="ctr"/>
+          <a:lstStyle/>
+          <a:p>
+            <a:pPr indent="0" marL="0">
+              <a:buNone/>
+            </a:pPr>
+            <a:r>
+              <a:rPr lang="en-US" sz="1200" dirty="0">
                 <a:solidFill>
                   <a:srgbClr val="D8E8CF"/>
                 </a:solidFill>
@@ -9518,7 +9518,7 @@
               </a:rPr>
               <a:t>L'application tourne en production et reste accessible en continu.</a:t>
             </a:r>
-            <a:endParaRPr lang="en-US" sz="1300" dirty="0"/>
+            <a:endParaRPr lang="en-US" sz="1200" dirty="0"/>
           </a:p>
         </p:txBody>
       </p:sp>
@@ -9530,12 +9530,12 @@
         </p:nvSpPr>
         <p:spPr>
           <a:xfrm>
-            <a:off x="6172200" y="1645920"/>
-            <a:ext cx="5440680" cy="1463040"/>
+            <a:off x="6172200" y="1572768"/>
+            <a:ext cx="5440680" cy="1207008"/>
           </a:xfrm>
           <a:prstGeom prst="roundRect">
             <a:avLst>
-              <a:gd name="adj" fmla="val 3750"/>
+              <a:gd name="adj" fmla="val 4545"/>
             </a:avLst>
           </a:prstGeom>
           <a:solidFill>
@@ -9557,24 +9557,24 @@
         </p:nvSpPr>
         <p:spPr>
           <a:xfrm>
-            <a:off x="6492240" y="1901952"/>
-            <a:ext cx="4800600" cy="347472"/>
-          </a:xfrm>
-          <a:prstGeom prst="rect">
-            <a:avLst/>
-          </a:prstGeom>
-          <a:noFill/>
-          <a:ln/>
-        </p:spPr>
-        <p:txBody>
-          <a:bodyPr wrap="square" lIns="0" tIns="0" rIns="0" bIns="0" rtlCol="0" anchor="ctr"/>
-          <a:lstStyle/>
-          <a:p>
-            <a:pPr indent="0" marL="0">
-              <a:buNone/>
-            </a:pPr>
-            <a:r>
-              <a:rPr lang="en-US" sz="2000" b="1" dirty="0">
+            <a:off x="6492240" y="1755648"/>
+            <a:ext cx="4800600" cy="329184"/>
+          </a:xfrm>
+          <a:prstGeom prst="rect">
+            <a:avLst/>
+          </a:prstGeom>
+          <a:noFill/>
+          <a:ln/>
+        </p:spPr>
+        <p:txBody>
+          <a:bodyPr wrap="square" lIns="0" tIns="0" rIns="0" bIns="0" rtlCol="0" anchor="ctr"/>
+          <a:lstStyle/>
+          <a:p>
+            <a:pPr indent="0" marL="0">
+              <a:buNone/>
+            </a:pPr>
+            <a:r>
+              <a:rPr lang="en-US" sz="1800" b="1" dirty="0">
                 <a:solidFill>
                   <a:srgbClr val="97BC62"/>
                 </a:solidFill>
@@ -9584,7 +9584,7 @@
               </a:rPr>
               <a:t>Conforme</a:t>
             </a:r>
-            <a:endParaRPr lang="en-US" sz="2000" dirty="0"/>
+            <a:endParaRPr lang="en-US" sz="1800" dirty="0"/>
           </a:p>
         </p:txBody>
       </p:sp>
@@ -9596,24 +9596,24 @@
         </p:nvSpPr>
         <p:spPr>
           <a:xfrm>
-            <a:off x="6492240" y="2331720"/>
-            <a:ext cx="4800600" cy="594360"/>
-          </a:xfrm>
-          <a:prstGeom prst="rect">
-            <a:avLst/>
-          </a:prstGeom>
-          <a:noFill/>
-          <a:ln/>
-        </p:spPr>
-        <p:txBody>
-          <a:bodyPr wrap="square" lIns="0" tIns="0" rIns="0" bIns="0" rtlCol="0" anchor="ctr"/>
-          <a:lstStyle/>
-          <a:p>
-            <a:pPr indent="0" marL="0">
-              <a:buNone/>
-            </a:pPr>
-            <a:r>
-              <a:rPr lang="en-US" sz="1300" dirty="0">
+            <a:off x="6492240" y="2139696"/>
+            <a:ext cx="4800600" cy="548640"/>
+          </a:xfrm>
+          <a:prstGeom prst="rect">
+            <a:avLst/>
+          </a:prstGeom>
+          <a:noFill/>
+          <a:ln/>
+        </p:spPr>
+        <p:txBody>
+          <a:bodyPr wrap="square" lIns="0" tIns="0" rIns="0" bIns="0" rtlCol="0" anchor="ctr"/>
+          <a:lstStyle/>
+          <a:p>
+            <a:pPr indent="0" marL="0">
+              <a:buNone/>
+            </a:pPr>
+            <a:r>
+              <a:rPr lang="en-US" sz="1200" dirty="0">
                 <a:solidFill>
                   <a:srgbClr val="D8E8CF"/>
                 </a:solidFill>
@@ -9623,7 +9623,7 @@
               </a:rPr>
               <a:t>Tous les objectifs du cahier des charges sont couverts et vérifiables.</a:t>
             </a:r>
-            <a:endParaRPr lang="en-US" sz="1300" dirty="0"/>
+            <a:endParaRPr lang="en-US" sz="1200" dirty="0"/>
           </a:p>
         </p:txBody>
       </p:sp>
@@ -9635,12 +9635,12 @@
         </p:nvSpPr>
         <p:spPr>
           <a:xfrm>
-            <a:off x="548640" y="3337560"/>
-            <a:ext cx="5440680" cy="1463040"/>
+            <a:off x="548640" y="2990088"/>
+            <a:ext cx="5440680" cy="1207008"/>
           </a:xfrm>
           <a:prstGeom prst="roundRect">
             <a:avLst>
-              <a:gd name="adj" fmla="val 3750"/>
+              <a:gd name="adj" fmla="val 4545"/>
             </a:avLst>
           </a:prstGeom>
           <a:solidFill>
@@ -9662,24 +9662,24 @@
         </p:nvSpPr>
         <p:spPr>
           <a:xfrm>
-            <a:off x="868680" y="3593592"/>
-            <a:ext cx="4800600" cy="347472"/>
-          </a:xfrm>
-          <a:prstGeom prst="rect">
-            <a:avLst/>
-          </a:prstGeom>
-          <a:noFill/>
-          <a:ln/>
-        </p:spPr>
-        <p:txBody>
-          <a:bodyPr wrap="square" lIns="0" tIns="0" rIns="0" bIns="0" rtlCol="0" anchor="ctr"/>
-          <a:lstStyle/>
-          <a:p>
-            <a:pPr indent="0" marL="0">
-              <a:buNone/>
-            </a:pPr>
-            <a:r>
-              <a:rPr lang="en-US" sz="2000" b="1" dirty="0">
+            <a:off x="868680" y="3172968"/>
+            <a:ext cx="4800600" cy="329184"/>
+          </a:xfrm>
+          <a:prstGeom prst="rect">
+            <a:avLst/>
+          </a:prstGeom>
+          <a:noFill/>
+          <a:ln/>
+        </p:spPr>
+        <p:txBody>
+          <a:bodyPr wrap="square" lIns="0" tIns="0" rIns="0" bIns="0" rtlCol="0" anchor="ctr"/>
+          <a:lstStyle/>
+          <a:p>
+            <a:pPr indent="0" marL="0">
+              <a:buNone/>
+            </a:pPr>
+            <a:r>
+              <a:rPr lang="en-US" sz="1800" b="1" dirty="0">
                 <a:solidFill>
                   <a:srgbClr val="97BC62"/>
                 </a:solidFill>
@@ -9689,7 +9689,7 @@
               </a:rPr>
               <a:t>Documenté</a:t>
             </a:r>
-            <a:endParaRPr lang="en-US" sz="2000" dirty="0"/>
+            <a:endParaRPr lang="en-US" sz="1800" dirty="0"/>
           </a:p>
         </p:txBody>
       </p:sp>
@@ -9701,24 +9701,24 @@
         </p:nvSpPr>
         <p:spPr>
           <a:xfrm>
-            <a:off x="868680" y="4023360"/>
-            <a:ext cx="4800600" cy="594360"/>
-          </a:xfrm>
-          <a:prstGeom prst="rect">
-            <a:avLst/>
-          </a:prstGeom>
-          <a:noFill/>
-          <a:ln/>
-        </p:spPr>
-        <p:txBody>
-          <a:bodyPr wrap="square" lIns="0" tIns="0" rIns="0" bIns="0" rtlCol="0" anchor="ctr"/>
-          <a:lstStyle/>
-          <a:p>
-            <a:pPr indent="0" marL="0">
-              <a:buNone/>
-            </a:pPr>
-            <a:r>
-              <a:rPr lang="en-US" sz="1300" dirty="0">
+            <a:off x="868680" y="3557016"/>
+            <a:ext cx="4800600" cy="548640"/>
+          </a:xfrm>
+          <a:prstGeom prst="rect">
+            <a:avLst/>
+          </a:prstGeom>
+          <a:noFill/>
+          <a:ln/>
+        </p:spPr>
+        <p:txBody>
+          <a:bodyPr wrap="square" lIns="0" tIns="0" rIns="0" bIns="0" rtlCol="0" anchor="ctr"/>
+          <a:lstStyle/>
+          <a:p>
+            <a:pPr indent="0" marL="0">
+              <a:buNone/>
+            </a:pPr>
+            <a:r>
+              <a:rPr lang="en-US" sz="1200" dirty="0">
                 <a:solidFill>
                   <a:srgbClr val="D8E8CF"/>
                 </a:solidFill>
@@ -9728,7 +9728,7 @@
               </a:rPr>
               <a:t>Architecture réseau, justifications techniques et guide de déploiement rédigés.</a:t>
             </a:r>
-            <a:endParaRPr lang="en-US" sz="1300" dirty="0"/>
+            <a:endParaRPr lang="en-US" sz="1200" dirty="0"/>
           </a:p>
         </p:txBody>
       </p:sp>
@@ -9740,12 +9740,12 @@
         </p:nvSpPr>
         <p:spPr>
           <a:xfrm>
-            <a:off x="6172200" y="3337560"/>
-            <a:ext cx="5440680" cy="1463040"/>
+            <a:off x="6172200" y="2990088"/>
+            <a:ext cx="5440680" cy="1207008"/>
           </a:xfrm>
           <a:prstGeom prst="roundRect">
             <a:avLst>
-              <a:gd name="adj" fmla="val 3750"/>
+              <a:gd name="adj" fmla="val 4545"/>
             </a:avLst>
           </a:prstGeom>
           <a:solidFill>
@@ -9767,24 +9767,24 @@
         </p:nvSpPr>
         <p:spPr>
           <a:xfrm>
-            <a:off x="6492240" y="3593592"/>
-            <a:ext cx="4800600" cy="347472"/>
-          </a:xfrm>
-          <a:prstGeom prst="rect">
-            <a:avLst/>
-          </a:prstGeom>
-          <a:noFill/>
-          <a:ln/>
-        </p:spPr>
-        <p:txBody>
-          <a:bodyPr wrap="square" lIns="0" tIns="0" rIns="0" bIns="0" rtlCol="0" anchor="ctr"/>
-          <a:lstStyle/>
-          <a:p>
-            <a:pPr indent="0" marL="0">
-              <a:buNone/>
-            </a:pPr>
-            <a:r>
-              <a:rPr lang="en-US" sz="2000" b="1" dirty="0">
+            <a:off x="6492240" y="3172968"/>
+            <a:ext cx="4800600" cy="329184"/>
+          </a:xfrm>
+          <a:prstGeom prst="rect">
+            <a:avLst/>
+          </a:prstGeom>
+          <a:noFill/>
+          <a:ln/>
+        </p:spPr>
+        <p:txBody>
+          <a:bodyPr wrap="square" lIns="0" tIns="0" rIns="0" bIns="0" rtlCol="0" anchor="ctr"/>
+          <a:lstStyle/>
+          <a:p>
+            <a:pPr indent="0" marL="0">
+              <a:buNone/>
+            </a:pPr>
+            <a:r>
+              <a:rPr lang="en-US" sz="1800" b="1" dirty="0">
                 <a:solidFill>
                   <a:srgbClr val="97BC62"/>
                 </a:solidFill>
@@ -9794,7 +9794,7 @@
               </a:rPr>
               <a:t>Évolutif</a:t>
             </a:r>
-            <a:endParaRPr lang="en-US" sz="2000" dirty="0"/>
+            <a:endParaRPr lang="en-US" sz="1800" dirty="0"/>
           </a:p>
         </p:txBody>
       </p:sp>
@@ -9806,24 +9806,24 @@
         </p:nvSpPr>
         <p:spPr>
           <a:xfrm>
-            <a:off x="6492240" y="4023360"/>
-            <a:ext cx="4800600" cy="594360"/>
-          </a:xfrm>
-          <a:prstGeom prst="rect">
-            <a:avLst/>
-          </a:prstGeom>
-          <a:noFill/>
-          <a:ln/>
-        </p:spPr>
-        <p:txBody>
-          <a:bodyPr wrap="square" lIns="0" tIns="0" rIns="0" bIns="0" rtlCol="0" anchor="ctr"/>
-          <a:lstStyle/>
-          <a:p>
-            <a:pPr indent="0" marL="0">
-              <a:buNone/>
-            </a:pPr>
-            <a:r>
-              <a:rPr lang="en-US" sz="1300" dirty="0">
+            <a:off x="6492240" y="3557016"/>
+            <a:ext cx="4800600" cy="548640"/>
+          </a:xfrm>
+          <a:prstGeom prst="rect">
+            <a:avLst/>
+          </a:prstGeom>
+          <a:noFill/>
+          <a:ln/>
+        </p:spPr>
+        <p:txBody>
+          <a:bodyPr wrap="square" lIns="0" tIns="0" rIns="0" bIns="0" rtlCol="0" anchor="ctr"/>
+          <a:lstStyle/>
+          <a:p>
+            <a:pPr indent="0" marL="0">
+              <a:buNone/>
+            </a:pPr>
+            <a:r>
+              <a:rPr lang="en-US" sz="1200" dirty="0">
                 <a:solidFill>
                   <a:srgbClr val="D8E8CF"/>
                 </a:solidFill>
@@ -9833,46 +9833,151 @@
               </a:rPr>
               <a:t>L'architecture supporte la montée en charge sans réécriture.</a:t>
             </a:r>
-            <a:endParaRPr lang="en-US" sz="1300" dirty="0"/>
-          </a:p>
-        </p:txBody>
-      </p:sp>
-      <p:sp>
-        <p:nvSpPr>
-          <p:cNvPr id="16" name="Text 14"/>
-          <p:cNvSpPr txBox="1"/>
-          <p:nvPr/>
-        </p:nvSpPr>
-        <p:spPr>
-          <a:xfrm>
-            <a:off x="548640" y="5257800"/>
-            <a:ext cx="11064240" cy="457200"/>
-          </a:xfrm>
-          <a:prstGeom prst="rect">
-            <a:avLst/>
-          </a:prstGeom>
-          <a:noFill/>
-          <a:ln/>
-        </p:spPr>
-        <p:txBody>
-          <a:bodyPr wrap="square" lIns="0" tIns="0" rIns="0" bIns="0" rtlCol="0" anchor="ctr"/>
-          <a:lstStyle/>
-          <a:p>
-            <a:pPr indent="0" marL="0">
-              <a:buNone/>
-            </a:pPr>
-            <a:r>
-              <a:rPr lang="en-US" sz="1800" b="1" i="1" dirty="0">
+            <a:endParaRPr lang="en-US" sz="1200" dirty="0"/>
+          </a:p>
+        </p:txBody>
+      </p:sp>
+      <p:sp>
+        <p:nvSpPr>
+          <p:cNvPr id="16" name="Shape 14"/>
+          <p:cNvSpPr/>
+          <p:nvPr/>
+        </p:nvSpPr>
+        <p:spPr>
+          <a:xfrm>
+            <a:off x="548640" y="4572000"/>
+            <a:ext cx="11064240" cy="1691640"/>
+          </a:xfrm>
+          <a:prstGeom prst="roundRect">
+            <a:avLst>
+              <a:gd name="adj" fmla="val 3243"/>
+            </a:avLst>
+          </a:prstGeom>
+          <a:solidFill>
+            <a:srgbClr val="2C5F2D"/>
+          </a:solidFill>
+          <a:ln w="12700">
+            <a:solidFill>
+              <a:srgbClr val="2C5F2D"/>
+            </a:solidFill>
+            <a:prstDash val="solid"/>
+          </a:ln>
+        </p:spPr>
+      </p:sp>
+      <p:sp>
+        <p:nvSpPr>
+          <p:cNvPr id="17" name="Text 15"/>
+          <p:cNvSpPr txBox="1"/>
+          <p:nvPr/>
+        </p:nvSpPr>
+        <p:spPr>
+          <a:xfrm>
+            <a:off x="868680" y="4736592"/>
+            <a:ext cx="10424160" cy="256032"/>
+          </a:xfrm>
+          <a:prstGeom prst="rect">
+            <a:avLst/>
+          </a:prstGeom>
+          <a:noFill/>
+          <a:ln/>
+        </p:spPr>
+        <p:txBody>
+          <a:bodyPr wrap="square" lIns="0" tIns="0" rIns="0" bIns="0" rtlCol="0" anchor="ctr"/>
+          <a:lstStyle/>
+          <a:p>
+            <a:pPr indent="0" marL="0">
+              <a:buNone/>
+            </a:pPr>
+            <a:r>
+              <a:rPr lang="en-US" sz="1100" b="1" spc="120" kern="0" dirty="0">
+                <a:solidFill>
+                  <a:srgbClr val="97BC62"/>
+                </a:solidFill>
+                <a:latin typeface="Calibri" pitchFamily="34" charset="0"/>
+                <a:ea typeface="Calibri" pitchFamily="34" charset="-122"/>
+                <a:cs typeface="Calibri" pitchFamily="34" charset="-120"/>
+              </a:rPr>
+              <a:t>VALIDÉ SUR LE TERRAIN, PAS SEULEMENT À L'ÉCOLE</a:t>
+            </a:r>
+            <a:endParaRPr lang="en-US" sz="1100" dirty="0"/>
+          </a:p>
+        </p:txBody>
+      </p:sp>
+      <p:sp>
+        <p:nvSpPr>
+          <p:cNvPr id="18" name="Text 16"/>
+          <p:cNvSpPr txBox="1"/>
+          <p:nvPr/>
+        </p:nvSpPr>
+        <p:spPr>
+          <a:xfrm>
+            <a:off x="868680" y="5029200"/>
+            <a:ext cx="10424160" cy="548640"/>
+          </a:xfrm>
+          <a:prstGeom prst="rect">
+            <a:avLst/>
+          </a:prstGeom>
+          <a:noFill/>
+          <a:ln/>
+        </p:spPr>
+        <p:txBody>
+          <a:bodyPr wrap="square" lIns="0" tIns="0" rIns="0" bIns="0" rtlCol="0" anchor="ctr"/>
+          <a:lstStyle/>
+          <a:p>
+            <a:pPr indent="0" marL="0">
+              <a:buNone/>
+            </a:pPr>
+            <a:r>
+              <a:rPr lang="en-US" sz="1350" dirty="0">
                 <a:solidFill>
                   <a:srgbClr val="FFFFFF"/>
                 </a:solidFill>
-                <a:latin typeface="Cambria" pitchFamily="34" charset="0"/>
-                <a:ea typeface="Cambria" pitchFamily="34" charset="-122"/>
-                <a:cs typeface="Cambria" pitchFamily="34" charset="-120"/>
-              </a:rPr>
-              <a:t>PlantDiag est immédiatement utilisable par un agriculteur, depuis son téléphone, dans son champ.</a:t>
-            </a:r>
-            <a:endParaRPr lang="en-US" sz="1800" dirty="0"/>
+                <a:latin typeface="Calibri" pitchFamily="34" charset="0"/>
+                <a:ea typeface="Calibri" pitchFamily="34" charset="-122"/>
+                <a:cs typeface="Calibri" pitchFamily="34" charset="-120"/>
+              </a:rPr>
+              <a:t>Testé par mon frère, agriculteur, directement dans sa ferme. Puis testé avec mon père, commercial dans le secteur agricole, auprès de plusieurs autres agriculteurs sur le terrain.</a:t>
+            </a:r>
+            <a:endParaRPr lang="en-US" sz="1350" dirty="0"/>
+          </a:p>
+        </p:txBody>
+      </p:sp>
+      <p:sp>
+        <p:nvSpPr>
+          <p:cNvPr id="19" name="Text 17"/>
+          <p:cNvSpPr txBox="1"/>
+          <p:nvPr/>
+        </p:nvSpPr>
+        <p:spPr>
+          <a:xfrm>
+            <a:off x="868680" y="5532120"/>
+            <a:ext cx="10424160" cy="548640"/>
+          </a:xfrm>
+          <a:prstGeom prst="rect">
+            <a:avLst/>
+          </a:prstGeom>
+          <a:noFill/>
+          <a:ln/>
+        </p:spPr>
+        <p:txBody>
+          <a:bodyPr wrap="square" lIns="0" tIns="0" rIns="0" bIns="0" rtlCol="0" anchor="ctr"/>
+          <a:lstStyle/>
+          <a:p>
+            <a:pPr indent="0" marL="0">
+              <a:buNone/>
+            </a:pPr>
+            <a:r>
+              <a:rPr lang="en-US" sz="1350" b="1" i="1" dirty="0">
+                <a:solidFill>
+                  <a:srgbClr val="D8E8CF"/>
+                </a:solidFill>
+                <a:latin typeface="Calibri" pitchFamily="34" charset="0"/>
+                <a:ea typeface="Calibri" pitchFamily="34" charset="-122"/>
+                <a:cs typeface="Calibri" pitchFamily="34" charset="-120"/>
+              </a:rPr>
+              <a:t>Le retour le plus fréquent : centraliser toutes leurs données au même endroit, et surtout croiser la météo avec le risque de maladie pour anticiper plutôt que subir.</a:t>
+            </a:r>
+            <a:endParaRPr lang="en-US" sz="1350" dirty="0"/>
           </a:p>
         </p:txBody>
       </p:sp>

</xml_diff>